<commit_message>
Replace dummy team identities with final five-member team
</commit_message>
<xml_diff>
--- a/Reports/Water_Quality_Prediction.pptx
+++ b/Reports/Water_Quality_Prediction.pptx
@@ -1523,7 +1523,7 @@
           <a:p>
             <a:r>
               <a:rPr lang="en-US" dirty="0"/>
-              <a:t>Project 18 compares a strong tabular baseline with an MLP on one continuous target. State the scope as source-index emulation from the start. Source: https://doi.org/10.6084/m9.figshare.27800394.v2. Decorative photo: David Kovalenko, https://unsplash.com/photos/birds-eye-view-of-river-and-green-trees-qYMa2-P-U0M, Unsplash license. The photograph does not depict a documented monitoring station. Team: Team Member 1 (Enrollment 1), Team Member 2 (Enrollment 2), Team Member 3 (Enrollment 3), Team Member 4 (Enrollment 4).</a:t>
+              <a:t>Project 18 compares a strong tabular baseline with an MLP on one continuous target. State the scope as source-index emulation from the start. Source: https://doi.org/10.6084/m9.figshare.27800394.v2. Decorative photo: David Kovalenko, https://unsplash.com/photos/birds-eye-view-of-river-and-green-trees-qYMa2-P-U0M, Unsplash license. The photograph does not depict a documented monitoring station. Team: Dhruv Kumar (2401010152), Ritesh (2041010383), Yash Kumar (2401010512), Parul (2401010321), Punit (2401010359).</a:t>
             </a:r>
             <a:endParaRPr lang="en-US" dirty="0"/>
           </a:p>
@@ -1787,7 +1787,7 @@
           <a:p>
             <a:r>
               <a:rPr lang="en-US" dirty="0"/>
-              <a:t>Dataset: https://doi.org/10.6084/m9.figshare.27800394.v2. Official standard: https://ccme.ca/en/res/wqimanualen.pdf. XGBoost: https://doi.org/10.1145/2939672.2939785. Feedforward networks: https://www.deeplearningbook.org/contents/mlp.html. Tabular benchmark: https://arxiv.org/abs/2207.08815. Uncertainty: https://arxiv.org/abs/2107.07511. Repository-organization reference: https://github.com/abhi-7-7/Flight_Delay_Prediction. Design inspiration: https://canva.link/jhwgwqkgeon4gbs. Team metadata intentionally contain dummy values at user request.</a:t>
+              <a:t>Dataset: https://doi.org/10.6084/m9.figshare.27800394.v2. Official standard: https://ccme.ca/en/res/wqimanualen.pdf. XGBoost: https://doi.org/10.1145/2939672.2939785. Feedforward networks: https://www.deeplearningbook.org/contents/mlp.html. Tabular benchmark: https://arxiv.org/abs/2207.08815. Uncertainty: https://arxiv.org/abs/2107.07511. Repository-organization reference: https://github.com/abhi-7-7/Flight_Delay_Prediction. Design inspiration: https://canva.link/jhwgwqkgeon4gbs. Team members: Dhruv Kumar (2401010152), Ritesh (2041010383), Yash Kumar (2401010512), Parul (2401010321), Punit (2401010359).</a:t>
             </a:r>
             <a:endParaRPr lang="en-US" dirty="0"/>
           </a:p>
@@ -2841,7 +2841,7 @@
 </file>
 
 <file path=ppt/slides/slide1.xml><?xml version="1.0" encoding="utf-8"?>
-<p:sld xmlns:a="http://schemas.openxmlformats.org/drawingml/2006/main" xmlns:r="http://schemas.openxmlformats.org/officeDocument/2006/relationships" xmlns:p="http://schemas.openxmlformats.org/presentationml/2006/main">
+<p:sld xmlns:a="http://schemas.openxmlformats.org/drawingml/2006/main" xmlns:p="http://schemas.openxmlformats.org/presentationml/2006/main" xmlns:r="http://schemas.openxmlformats.org/officeDocument/2006/relationships">
   <p:cSld name="Slide 1">
     <p:bg>
       <p:bgPr>
@@ -2866,7 +2866,7 @@
       </p:grpSpPr>
       <p:pic>
         <p:nvPicPr>
-          <p:cNvPr id="2" name="Image 0" descr="/Users/yashkumar/aiml_project/presentation/assets/river.jpg">    </p:cNvPr>
+          <p:cNvPr id="2" name="Image 0" descr="Aerial river photograph by David Kovalenko">    </p:cNvPr>
           <p:cNvPicPr>
             <a:picLocks noChangeAspect="1"/>
           </p:cNvPicPr>
@@ -3102,8 +3102,8 @@
         </p:nvSpPr>
         <p:spPr>
           <a:xfrm>
-            <a:off x="676656" y="5806440"/>
-            <a:ext cx="6035040" cy="320040"/>
+            <a:off x="676656" y="5404104"/>
+            <a:ext cx="6035040" cy="1188720"/>
           </a:xfrm>
           <a:prstGeom prst="rect">
             <a:avLst/>
@@ -3116,6 +3116,9 @@
           <a:lstStyle/>
           <a:p>
             <a:pPr indent="0" marL="0">
+              <a:lnSpc>
+                <a:spcPts val="1800"/>
+              </a:lnSpc>
               <a:buNone/>
             </a:pPr>
             <a:r>
@@ -3127,38 +3130,19 @@
                 <a:ea typeface="Arial" pitchFamily="34" charset="-122"/>
                 <a:cs typeface="Arial" pitchFamily="34" charset="-120"/>
               </a:rPr>
-              <a:t>TEAM-ID (replace)  /  SECTION (replace)</a:t>
+              <a:t>Dhruv Kumar  —  2401010152</a:t>
             </a:r>
             <a:endParaRPr lang="en-US" sz="1400" dirty="0"/>
           </a:p>
-        </p:txBody>
-      </p:sp>
-      <p:sp>
-        <p:nvSpPr>
-          <p:cNvPr id="8" name="Text 5"/>
-          <p:cNvSpPr/>
-          <p:nvPr/>
-        </p:nvSpPr>
-        <p:spPr>
-          <a:xfrm>
-            <a:off x="676656" y="6291072"/>
-            <a:ext cx="6035040" cy="228600"/>
-          </a:xfrm>
-          <a:prstGeom prst="rect">
-            <a:avLst/>
-          </a:prstGeom>
-          <a:noFill/>
-          <a:ln/>
-        </p:spPr>
-        <p:txBody>
-          <a:bodyPr wrap="square" lIns="0" tIns="0" rIns="0" bIns="0" rtlCol="0" anchor="t"/>
-          <a:lstStyle/>
-          <a:p>
-            <a:pPr indent="0" marL="0">
-              <a:buNone/>
-            </a:pPr>
-            <a:r>
-              <a:rPr lang="en-US" sz="1100" dirty="0">
+          <a:p>
+            <a:pPr indent="0" marL="0">
+              <a:lnSpc>
+                <a:spcPts val="1800"/>
+              </a:lnSpc>
+              <a:buNone/>
+            </a:pPr>
+            <a:r>
+              <a:rPr lang="en-US" sz="1400" dirty="0">
                 <a:solidFill>
                   <a:srgbClr val="59706E"/>
                 </a:solidFill>
@@ -3166,9 +3150,69 @@
                 <a:ea typeface="Arial" pitchFamily="34" charset="-122"/>
                 <a:cs typeface="Arial" pitchFamily="34" charset="-120"/>
               </a:rPr>
-              <a:t>Team details are editable dummy values</a:t>
-            </a:r>
-            <a:endParaRPr lang="en-US" sz="1100" dirty="0"/>
+              <a:t>Ritesh  —  2041010383</a:t>
+            </a:r>
+            <a:endParaRPr lang="en-US" sz="1400" dirty="0"/>
+          </a:p>
+          <a:p>
+            <a:pPr indent="0" marL="0">
+              <a:lnSpc>
+                <a:spcPts val="1800"/>
+              </a:lnSpc>
+              <a:buNone/>
+            </a:pPr>
+            <a:r>
+              <a:rPr lang="en-US" sz="1400" dirty="0">
+                <a:solidFill>
+                  <a:srgbClr val="59706E"/>
+                </a:solidFill>
+                <a:latin typeface="Arial" pitchFamily="34" charset="0"/>
+                <a:ea typeface="Arial" pitchFamily="34" charset="-122"/>
+                <a:cs typeface="Arial" pitchFamily="34" charset="-120"/>
+              </a:rPr>
+              <a:t>Yash Kumar  —  2401010512</a:t>
+            </a:r>
+            <a:endParaRPr lang="en-US" sz="1400" dirty="0"/>
+          </a:p>
+          <a:p>
+            <a:pPr indent="0" marL="0">
+              <a:lnSpc>
+                <a:spcPts val="1800"/>
+              </a:lnSpc>
+              <a:buNone/>
+            </a:pPr>
+            <a:r>
+              <a:rPr lang="en-US" sz="1400" dirty="0">
+                <a:solidFill>
+                  <a:srgbClr val="59706E"/>
+                </a:solidFill>
+                <a:latin typeface="Arial" pitchFamily="34" charset="0"/>
+                <a:ea typeface="Arial" pitchFamily="34" charset="-122"/>
+                <a:cs typeface="Arial" pitchFamily="34" charset="-120"/>
+              </a:rPr>
+              <a:t>Parul  —  2401010321</a:t>
+            </a:r>
+            <a:endParaRPr lang="en-US" sz="1400" dirty="0"/>
+          </a:p>
+          <a:p>
+            <a:pPr indent="0" marL="0">
+              <a:lnSpc>
+                <a:spcPts val="1800"/>
+              </a:lnSpc>
+              <a:buNone/>
+            </a:pPr>
+            <a:r>
+              <a:rPr lang="en-US" sz="1400" dirty="0">
+                <a:solidFill>
+                  <a:srgbClr val="59706E"/>
+                </a:solidFill>
+                <a:latin typeface="Arial" pitchFamily="34" charset="0"/>
+                <a:ea typeface="Arial" pitchFamily="34" charset="-122"/>
+                <a:cs typeface="Arial" pitchFamily="34" charset="-120"/>
+              </a:rPr>
+              <a:t>Punit  —  2401010359</a:t>
+            </a:r>
+            <a:endParaRPr lang="en-US" sz="1400" dirty="0"/>
           </a:p>
         </p:txBody>
       </p:sp>

</xml_diff>